<commit_message>
Final submission: 7-model ensemble, autoencoder, 9-page dashboard, adversarial testing, PDF report
</commit_message>
<xml_diff>
--- a/FraudShield_AI_Presentation.pptx
+++ b/FraudShield_AI_Presentation.pptx
@@ -5,21 +5,21 @@
     <p:sldMasterId id="2147483648" r:id="rId1"/>
   </p:sldMasterIdLst>
   <p:sldIdLst>
-    <p:sldId id="256" r:id="rId7"/>
-    <p:sldId id="257" r:id="rId8"/>
-    <p:sldId id="258" r:id="rId9"/>
-    <p:sldId id="259" r:id="rId10"/>
-    <p:sldId id="260" r:id="rId11"/>
-    <p:sldId id="261" r:id="rId12"/>
-    <p:sldId id="262" r:id="rId13"/>
-    <p:sldId id="263" r:id="rId14"/>
-    <p:sldId id="264" r:id="rId15"/>
-    <p:sldId id="265" r:id="rId16"/>
-    <p:sldId id="266" r:id="rId17"/>
-    <p:sldId id="267" r:id="rId18"/>
-    <p:sldId id="268" r:id="rId19"/>
+    <p:sldId id="256" r:id="rId2"/>
+    <p:sldId id="257" r:id="rId3"/>
+    <p:sldId id="258" r:id="rId4"/>
+    <p:sldId id="259" r:id="rId5"/>
+    <p:sldId id="260" r:id="rId6"/>
+    <p:sldId id="261" r:id="rId7"/>
+    <p:sldId id="262" r:id="rId8"/>
+    <p:sldId id="263" r:id="rId9"/>
+    <p:sldId id="264" r:id="rId10"/>
+    <p:sldId id="265" r:id="rId11"/>
+    <p:sldId id="266" r:id="rId12"/>
+    <p:sldId id="267" r:id="rId13"/>
+    <p:sldId id="268" r:id="rId14"/>
   </p:sldIdLst>
-  <p:sldSz cx="12191695" cy="6858000" type="screen4x3"/>
+  <p:sldSz cx="12192000" cy="6858000"/>
   <p:notesSz cx="6858000" cy="9144000"/>
   <p:defaultTextStyle>
     <a:defPPr>
@@ -116,7 +116,142 @@
       </a:defRPr>
     </a:lvl9pPr>
   </p:defaultTextStyle>
+  <p:extLst>
+    <p:ext uri="{EFAFB233-063F-42B5-8137-9DF3F51BA10A}">
+      <p15:sldGuideLst xmlns:p15="http://schemas.microsoft.com/office/powerpoint/2012/main">
+        <p15:guide id="1" orient="horz" pos="2160">
+          <p15:clr>
+            <a:srgbClr val="A4A3A4"/>
+          </p15:clr>
+        </p15:guide>
+        <p15:guide id="2" pos="2880">
+          <p15:clr>
+            <a:srgbClr val="A4A3A4"/>
+          </p15:clr>
+        </p15:guide>
+      </p15:sldGuideLst>
+    </p:ext>
+  </p:extLst>
 </p:presentation>
+</file>
+
+<file path=ppt/commentAuthors.xml><?xml version="1.0" encoding="utf-8"?>
+<p:cmAuthorLst xmlns:a="http://schemas.openxmlformats.org/drawingml/2006/main" xmlns:r="http://schemas.openxmlformats.org/officeDocument/2006/relationships" xmlns:p="http://schemas.openxmlformats.org/presentationml/2006/main">
+  <p:cmAuthor id="1" name="Jetash Jethi" initials="JJ" lastIdx="1" clrIdx="0">
+    <p:extLst>
+      <p:ext uri="{19B8F6BF-5375-455C-9EA6-DF929625EA0E}">
+        <p15:presenceInfo xmlns:p15="http://schemas.microsoft.com/office/powerpoint/2012/main" userId="9c40ca269f8fdef5" providerId="Windows Live"/>
+      </p:ext>
+    </p:extLst>
+  </p:cmAuthor>
+</p:cmAuthorLst>
+</file>
+
+<file path=ppt/changesInfos/changesInfo1.xml><?xml version="1.0" encoding="utf-8"?>
+<pc:chgInfo xmlns:a="http://schemas.openxmlformats.org/drawingml/2006/main" xmlns:r="http://schemas.openxmlformats.org/officeDocument/2006/relationships" xmlns:ac="http://schemas.microsoft.com/office/drawing/2013/main/command" xmlns:pc="http://schemas.microsoft.com/office/powerpoint/2013/main/command">
+  <pc:docChgLst>
+    <pc:chgData name="Jetash Jethi" userId="9c40ca269f8fdef5" providerId="LiveId" clId="{624E2C4E-3377-4979-BFA9-4160750A4C16}"/>
+    <pc:docChg chg="custSel modSld">
+      <pc:chgData name="Jetash Jethi" userId="9c40ca269f8fdef5" providerId="LiveId" clId="{624E2C4E-3377-4979-BFA9-4160750A4C16}" dt="2026-03-14T13:04:55.266" v="174" actId="1076"/>
+      <pc:docMkLst>
+        <pc:docMk/>
+      </pc:docMkLst>
+      <pc:sldChg chg="modSp mod">
+        <pc:chgData name="Jetash Jethi" userId="9c40ca269f8fdef5" providerId="LiveId" clId="{624E2C4E-3377-4979-BFA9-4160750A4C16}" dt="2026-03-14T13:03:17.574" v="173" actId="20577"/>
+        <pc:sldMkLst>
+          <pc:docMk/>
+          <pc:sldMk cId="0" sldId="256"/>
+        </pc:sldMkLst>
+        <pc:spChg chg="mod">
+          <ac:chgData name="Jetash Jethi" userId="9c40ca269f8fdef5" providerId="LiveId" clId="{624E2C4E-3377-4979-BFA9-4160750A4C16}" dt="2026-03-14T13:03:17.574" v="173" actId="20577"/>
+          <ac:spMkLst>
+            <pc:docMk/>
+            <pc:sldMk cId="0" sldId="256"/>
+            <ac:spMk id="6" creationId="{00000000-0000-0000-0000-000000000000}"/>
+          </ac:spMkLst>
+        </pc:spChg>
+      </pc:sldChg>
+      <pc:sldChg chg="modSp mod">
+        <pc:chgData name="Jetash Jethi" userId="9c40ca269f8fdef5" providerId="LiveId" clId="{624E2C4E-3377-4979-BFA9-4160750A4C16}" dt="2026-03-13T17:41:19.584" v="5" actId="122"/>
+        <pc:sldMkLst>
+          <pc:docMk/>
+          <pc:sldMk cId="0" sldId="261"/>
+        </pc:sldMkLst>
+        <pc:spChg chg="mod">
+          <ac:chgData name="Jetash Jethi" userId="9c40ca269f8fdef5" providerId="LiveId" clId="{624E2C4E-3377-4979-BFA9-4160750A4C16}" dt="2026-03-13T17:40:47.248" v="2" actId="1076"/>
+          <ac:spMkLst>
+            <pc:docMk/>
+            <pc:sldMk cId="0" sldId="261"/>
+            <ac:spMk id="74" creationId="{00000000-0000-0000-0000-000000000000}"/>
+          </ac:spMkLst>
+        </pc:spChg>
+        <pc:spChg chg="mod">
+          <ac:chgData name="Jetash Jethi" userId="9c40ca269f8fdef5" providerId="LiveId" clId="{624E2C4E-3377-4979-BFA9-4160750A4C16}" dt="2026-03-13T17:41:19.584" v="5" actId="122"/>
+          <ac:spMkLst>
+            <pc:docMk/>
+            <pc:sldMk cId="0" sldId="261"/>
+            <ac:spMk id="75" creationId="{00000000-0000-0000-0000-000000000000}"/>
+          </ac:spMkLst>
+        </pc:spChg>
+      </pc:sldChg>
+      <pc:sldChg chg="delSp modSp mod">
+        <pc:chgData name="Jetash Jethi" userId="9c40ca269f8fdef5" providerId="LiveId" clId="{624E2C4E-3377-4979-BFA9-4160750A4C16}" dt="2026-03-14T13:04:55.266" v="174" actId="1076"/>
+        <pc:sldMkLst>
+          <pc:docMk/>
+          <pc:sldMk cId="0" sldId="268"/>
+        </pc:sldMkLst>
+        <pc:spChg chg="del mod">
+          <ac:chgData name="Jetash Jethi" userId="9c40ca269f8fdef5" providerId="LiveId" clId="{624E2C4E-3377-4979-BFA9-4160750A4C16}" dt="2026-03-14T12:58:11.640" v="20" actId="478"/>
+          <ac:spMkLst>
+            <pc:docMk/>
+            <pc:sldMk cId="0" sldId="268"/>
+            <ac:spMk id="2" creationId="{00000000-0000-0000-0000-000000000000}"/>
+          </ac:spMkLst>
+        </pc:spChg>
+        <pc:spChg chg="del">
+          <ac:chgData name="Jetash Jethi" userId="9c40ca269f8fdef5" providerId="LiveId" clId="{624E2C4E-3377-4979-BFA9-4160750A4C16}" dt="2026-03-14T12:58:05.162" v="10" actId="478"/>
+          <ac:spMkLst>
+            <pc:docMk/>
+            <pc:sldMk cId="0" sldId="268"/>
+            <ac:spMk id="3" creationId="{00000000-0000-0000-0000-000000000000}"/>
+          </ac:spMkLst>
+        </pc:spChg>
+        <pc:spChg chg="del mod">
+          <ac:chgData name="Jetash Jethi" userId="9c40ca269f8fdef5" providerId="LiveId" clId="{624E2C4E-3377-4979-BFA9-4160750A4C16}" dt="2026-03-14T12:58:05.177" v="12"/>
+          <ac:spMkLst>
+            <pc:docMk/>
+            <pc:sldMk cId="0" sldId="268"/>
+            <ac:spMk id="4" creationId="{00000000-0000-0000-0000-000000000000}"/>
+          </ac:spMkLst>
+        </pc:spChg>
+        <pc:spChg chg="del mod">
+          <ac:chgData name="Jetash Jethi" userId="9c40ca269f8fdef5" providerId="LiveId" clId="{624E2C4E-3377-4979-BFA9-4160750A4C16}" dt="2026-03-14T12:58:39.077" v="116" actId="478"/>
+          <ac:spMkLst>
+            <pc:docMk/>
+            <pc:sldMk cId="0" sldId="268"/>
+            <ac:spMk id="5" creationId="{00000000-0000-0000-0000-000000000000}"/>
+          </ac:spMkLst>
+        </pc:spChg>
+        <pc:spChg chg="mod">
+          <ac:chgData name="Jetash Jethi" userId="9c40ca269f8fdef5" providerId="LiveId" clId="{624E2C4E-3377-4979-BFA9-4160750A4C16}" dt="2026-03-14T12:59:15.560" v="119" actId="1076"/>
+          <ac:spMkLst>
+            <pc:docMk/>
+            <pc:sldMk cId="0" sldId="268"/>
+            <ac:spMk id="6" creationId="{00000000-0000-0000-0000-000000000000}"/>
+          </ac:spMkLst>
+        </pc:spChg>
+        <pc:spChg chg="mod">
+          <ac:chgData name="Jetash Jethi" userId="9c40ca269f8fdef5" providerId="LiveId" clId="{624E2C4E-3377-4979-BFA9-4160750A4C16}" dt="2026-03-14T13:04:55.266" v="174" actId="1076"/>
+          <ac:spMkLst>
+            <pc:docMk/>
+            <pc:sldMk cId="0" sldId="268"/>
+            <ac:spMk id="7" creationId="{00000000-0000-0000-0000-000000000000}"/>
+          </ac:spMkLst>
+        </pc:spChg>
+      </pc:sldChg>
+    </pc:docChg>
+  </pc:docChgLst>
+</pc:chgInfo>
 </file>
 
 <file path=ppt/slideLayouts/slideLayout1.xml><?xml version="1.0" encoding="utf-8"?>
@@ -157,10 +292,9 @@
           <a:lstStyle/>
           <a:p>
             <a:r>
-              <a:rPr lang="en-US" smtClean="0"/>
+              <a:rPr lang="en-US"/>
               <a:t>Click to edit Master title style</a:t>
             </a:r>
-            <a:endParaRPr lang="en-US"/>
           </a:p>
         </p:txBody>
       </p:sp>
@@ -276,10 +410,9 @@
           </a:lstStyle>
           <a:p>
             <a:r>
-              <a:rPr lang="en-US" smtClean="0"/>
+              <a:rPr lang="en-US"/>
               <a:t>Click to edit Master subtitle style</a:t>
             </a:r>
-            <a:endParaRPr lang="en-US"/>
           </a:p>
         </p:txBody>
       </p:sp>
@@ -300,7 +433,7 @@
           <a:p>
             <a:fld id="{5BCAD085-E8A6-8845-BD4E-CB4CCA059FC4}" type="datetimeFigureOut">
               <a:rPr lang="en-US" smtClean="0"/>
-              <a:t>1/27/13</a:t>
+              <a:t>3/14/2026</a:t>
             </a:fld>
             <a:endParaRPr lang="en-US"/>
           </a:p>
@@ -394,10 +527,9 @@
           <a:lstStyle/>
           <a:p>
             <a:r>
-              <a:rPr lang="en-US" smtClean="0"/>
+              <a:rPr lang="en-US"/>
               <a:t>Click to edit Master title style</a:t>
             </a:r>
-            <a:endParaRPr lang="en-US"/>
           </a:p>
         </p:txBody>
       </p:sp>
@@ -418,38 +550,37 @@
           <a:p>
             <a:pPr lvl="0"/>
             <a:r>
-              <a:rPr lang="en-US" smtClean="0"/>
+              <a:rPr lang="en-US"/>
               <a:t>Click to edit Master text styles</a:t>
             </a:r>
           </a:p>
           <a:p>
             <a:pPr lvl="1"/>
             <a:r>
-              <a:rPr lang="en-US" smtClean="0"/>
+              <a:rPr lang="en-US"/>
               <a:t>Second level</a:t>
             </a:r>
           </a:p>
           <a:p>
             <a:pPr lvl="2"/>
             <a:r>
-              <a:rPr lang="en-US" smtClean="0"/>
+              <a:rPr lang="en-US"/>
               <a:t>Third level</a:t>
             </a:r>
           </a:p>
           <a:p>
             <a:pPr lvl="3"/>
             <a:r>
-              <a:rPr lang="en-US" smtClean="0"/>
+              <a:rPr lang="en-US"/>
               <a:t>Fourth level</a:t>
             </a:r>
           </a:p>
           <a:p>
             <a:pPr lvl="4"/>
             <a:r>
-              <a:rPr lang="en-US" smtClean="0"/>
+              <a:rPr lang="en-US"/>
               <a:t>Fifth level</a:t>
             </a:r>
-            <a:endParaRPr lang="en-US"/>
           </a:p>
         </p:txBody>
       </p:sp>
@@ -470,7 +601,7 @@
           <a:p>
             <a:fld id="{5BCAD085-E8A6-8845-BD4E-CB4CCA059FC4}" type="datetimeFigureOut">
               <a:rPr lang="en-US" smtClean="0"/>
-              <a:t>1/27/13</a:t>
+              <a:t>3/14/2026</a:t>
             </a:fld>
             <a:endParaRPr lang="en-US"/>
           </a:p>
@@ -569,10 +700,9 @@
           <a:lstStyle/>
           <a:p>
             <a:r>
-              <a:rPr lang="en-US" smtClean="0"/>
+              <a:rPr lang="en-US"/>
               <a:t>Click to edit Master title style</a:t>
             </a:r>
-            <a:endParaRPr lang="en-US"/>
           </a:p>
         </p:txBody>
       </p:sp>
@@ -598,38 +728,37 @@
           <a:p>
             <a:pPr lvl="0"/>
             <a:r>
-              <a:rPr lang="en-US" smtClean="0"/>
+              <a:rPr lang="en-US"/>
               <a:t>Click to edit Master text styles</a:t>
             </a:r>
           </a:p>
           <a:p>
             <a:pPr lvl="1"/>
             <a:r>
-              <a:rPr lang="en-US" smtClean="0"/>
+              <a:rPr lang="en-US"/>
               <a:t>Second level</a:t>
             </a:r>
           </a:p>
           <a:p>
             <a:pPr lvl="2"/>
             <a:r>
-              <a:rPr lang="en-US" smtClean="0"/>
+              <a:rPr lang="en-US"/>
               <a:t>Third level</a:t>
             </a:r>
           </a:p>
           <a:p>
             <a:pPr lvl="3"/>
             <a:r>
-              <a:rPr lang="en-US" smtClean="0"/>
+              <a:rPr lang="en-US"/>
               <a:t>Fourth level</a:t>
             </a:r>
           </a:p>
           <a:p>
             <a:pPr lvl="4"/>
             <a:r>
-              <a:rPr lang="en-US" smtClean="0"/>
+              <a:rPr lang="en-US"/>
               <a:t>Fifth level</a:t>
             </a:r>
-            <a:endParaRPr lang="en-US"/>
           </a:p>
         </p:txBody>
       </p:sp>
@@ -650,7 +779,7 @@
           <a:p>
             <a:fld id="{5BCAD085-E8A6-8845-BD4E-CB4CCA059FC4}" type="datetimeFigureOut">
               <a:rPr lang="en-US" smtClean="0"/>
-              <a:t>1/27/13</a:t>
+              <a:t>3/14/2026</a:t>
             </a:fld>
             <a:endParaRPr lang="en-US"/>
           </a:p>
@@ -744,10 +873,9 @@
           <a:lstStyle/>
           <a:p>
             <a:r>
-              <a:rPr lang="en-US" smtClean="0"/>
+              <a:rPr lang="en-US"/>
               <a:t>Click to edit Master title style</a:t>
             </a:r>
-            <a:endParaRPr lang="en-US"/>
           </a:p>
         </p:txBody>
       </p:sp>
@@ -768,38 +896,37 @@
           <a:p>
             <a:pPr lvl="0"/>
             <a:r>
-              <a:rPr lang="en-US" smtClean="0"/>
+              <a:rPr lang="en-US"/>
               <a:t>Click to edit Master text styles</a:t>
             </a:r>
           </a:p>
           <a:p>
             <a:pPr lvl="1"/>
             <a:r>
-              <a:rPr lang="en-US" smtClean="0"/>
+              <a:rPr lang="en-US"/>
               <a:t>Second level</a:t>
             </a:r>
           </a:p>
           <a:p>
             <a:pPr lvl="2"/>
             <a:r>
-              <a:rPr lang="en-US" smtClean="0"/>
+              <a:rPr lang="en-US"/>
               <a:t>Third level</a:t>
             </a:r>
           </a:p>
           <a:p>
             <a:pPr lvl="3"/>
             <a:r>
-              <a:rPr lang="en-US" smtClean="0"/>
+              <a:rPr lang="en-US"/>
               <a:t>Fourth level</a:t>
             </a:r>
           </a:p>
           <a:p>
             <a:pPr lvl="4"/>
             <a:r>
-              <a:rPr lang="en-US" smtClean="0"/>
+              <a:rPr lang="en-US"/>
               <a:t>Fifth level</a:t>
             </a:r>
-            <a:endParaRPr lang="en-US"/>
           </a:p>
         </p:txBody>
       </p:sp>
@@ -820,7 +947,7 @@
           <a:p>
             <a:fld id="{5BCAD085-E8A6-8845-BD4E-CB4CCA059FC4}" type="datetimeFigureOut">
               <a:rPr lang="en-US" smtClean="0"/>
-              <a:t>1/27/13</a:t>
+              <a:t>3/14/2026</a:t>
             </a:fld>
             <a:endParaRPr lang="en-US"/>
           </a:p>
@@ -923,10 +1050,9 @@
           </a:lstStyle>
           <a:p>
             <a:r>
-              <a:rPr lang="en-US" smtClean="0"/>
+              <a:rPr lang="en-US"/>
               <a:t>Click to edit Master title style</a:t>
             </a:r>
-            <a:endParaRPr lang="en-US"/>
           </a:p>
         </p:txBody>
       </p:sp>
@@ -1043,7 +1169,7 @@
           <a:p>
             <a:pPr lvl="0"/>
             <a:r>
-              <a:rPr lang="en-US" smtClean="0"/>
+              <a:rPr lang="en-US"/>
               <a:t>Click to edit Master text styles</a:t>
             </a:r>
           </a:p>
@@ -1066,7 +1192,7 @@
           <a:p>
             <a:fld id="{5BCAD085-E8A6-8845-BD4E-CB4CCA059FC4}" type="datetimeFigureOut">
               <a:rPr lang="en-US" smtClean="0"/>
-              <a:t>1/27/13</a:t>
+              <a:t>3/14/2026</a:t>
             </a:fld>
             <a:endParaRPr lang="en-US"/>
           </a:p>
@@ -1160,10 +1286,9 @@
           <a:lstStyle/>
           <a:p>
             <a:r>
-              <a:rPr lang="en-US" smtClean="0"/>
+              <a:rPr lang="en-US"/>
               <a:t>Click to edit Master title style</a:t>
             </a:r>
-            <a:endParaRPr lang="en-US"/>
           </a:p>
         </p:txBody>
       </p:sp>
@@ -1217,38 +1342,37 @@
           <a:p>
             <a:pPr lvl="0"/>
             <a:r>
-              <a:rPr lang="en-US" smtClean="0"/>
+              <a:rPr lang="en-US"/>
               <a:t>Click to edit Master text styles</a:t>
             </a:r>
           </a:p>
           <a:p>
             <a:pPr lvl="1"/>
             <a:r>
-              <a:rPr lang="en-US" smtClean="0"/>
+              <a:rPr lang="en-US"/>
               <a:t>Second level</a:t>
             </a:r>
           </a:p>
           <a:p>
             <a:pPr lvl="2"/>
             <a:r>
-              <a:rPr lang="en-US" smtClean="0"/>
+              <a:rPr lang="en-US"/>
               <a:t>Third level</a:t>
             </a:r>
           </a:p>
           <a:p>
             <a:pPr lvl="3"/>
             <a:r>
-              <a:rPr lang="en-US" smtClean="0"/>
+              <a:rPr lang="en-US"/>
               <a:t>Fourth level</a:t>
             </a:r>
           </a:p>
           <a:p>
             <a:pPr lvl="4"/>
             <a:r>
-              <a:rPr lang="en-US" smtClean="0"/>
+              <a:rPr lang="en-US"/>
               <a:t>Fifth level</a:t>
             </a:r>
-            <a:endParaRPr lang="en-US"/>
           </a:p>
         </p:txBody>
       </p:sp>
@@ -1302,38 +1426,37 @@
           <a:p>
             <a:pPr lvl="0"/>
             <a:r>
-              <a:rPr lang="en-US" smtClean="0"/>
+              <a:rPr lang="en-US"/>
               <a:t>Click to edit Master text styles</a:t>
             </a:r>
           </a:p>
           <a:p>
             <a:pPr lvl="1"/>
             <a:r>
-              <a:rPr lang="en-US" smtClean="0"/>
+              <a:rPr lang="en-US"/>
               <a:t>Second level</a:t>
             </a:r>
           </a:p>
           <a:p>
             <a:pPr lvl="2"/>
             <a:r>
-              <a:rPr lang="en-US" smtClean="0"/>
+              <a:rPr lang="en-US"/>
               <a:t>Third level</a:t>
             </a:r>
           </a:p>
           <a:p>
             <a:pPr lvl="3"/>
             <a:r>
-              <a:rPr lang="en-US" smtClean="0"/>
+              <a:rPr lang="en-US"/>
               <a:t>Fourth level</a:t>
             </a:r>
           </a:p>
           <a:p>
             <a:pPr lvl="4"/>
             <a:r>
-              <a:rPr lang="en-US" smtClean="0"/>
+              <a:rPr lang="en-US"/>
               <a:t>Fifth level</a:t>
             </a:r>
-            <a:endParaRPr lang="en-US"/>
           </a:p>
         </p:txBody>
       </p:sp>
@@ -1354,7 +1477,7 @@
           <a:p>
             <a:fld id="{5BCAD085-E8A6-8845-BD4E-CB4CCA059FC4}" type="datetimeFigureOut">
               <a:rPr lang="en-US" smtClean="0"/>
-              <a:t>1/27/13</a:t>
+              <a:t>3/14/2026</a:t>
             </a:fld>
             <a:endParaRPr lang="en-US"/>
           </a:p>
@@ -1452,10 +1575,9 @@
           </a:lstStyle>
           <a:p>
             <a:r>
-              <a:rPr lang="en-US" smtClean="0"/>
+              <a:rPr lang="en-US"/>
               <a:t>Click to edit Master title style</a:t>
             </a:r>
-            <a:endParaRPr lang="en-US"/>
           </a:p>
         </p:txBody>
       </p:sp>
@@ -1518,7 +1640,7 @@
           <a:p>
             <a:pPr lvl="0"/>
             <a:r>
-              <a:rPr lang="en-US" smtClean="0"/>
+              <a:rPr lang="en-US"/>
               <a:t>Click to edit Master text styles</a:t>
             </a:r>
           </a:p>
@@ -1574,38 +1696,37 @@
           <a:p>
             <a:pPr lvl="0"/>
             <a:r>
-              <a:rPr lang="en-US" smtClean="0"/>
+              <a:rPr lang="en-US"/>
               <a:t>Click to edit Master text styles</a:t>
             </a:r>
           </a:p>
           <a:p>
             <a:pPr lvl="1"/>
             <a:r>
-              <a:rPr lang="en-US" smtClean="0"/>
+              <a:rPr lang="en-US"/>
               <a:t>Second level</a:t>
             </a:r>
           </a:p>
           <a:p>
             <a:pPr lvl="2"/>
             <a:r>
-              <a:rPr lang="en-US" smtClean="0"/>
+              <a:rPr lang="en-US"/>
               <a:t>Third level</a:t>
             </a:r>
           </a:p>
           <a:p>
             <a:pPr lvl="3"/>
             <a:r>
-              <a:rPr lang="en-US" smtClean="0"/>
+              <a:rPr lang="en-US"/>
               <a:t>Fourth level</a:t>
             </a:r>
           </a:p>
           <a:p>
             <a:pPr lvl="4"/>
             <a:r>
-              <a:rPr lang="en-US" smtClean="0"/>
+              <a:rPr lang="en-US"/>
               <a:t>Fifth level</a:t>
             </a:r>
-            <a:endParaRPr lang="en-US"/>
           </a:p>
         </p:txBody>
       </p:sp>
@@ -1668,7 +1789,7 @@
           <a:p>
             <a:pPr lvl="0"/>
             <a:r>
-              <a:rPr lang="en-US" smtClean="0"/>
+              <a:rPr lang="en-US"/>
               <a:t>Click to edit Master text styles</a:t>
             </a:r>
           </a:p>
@@ -1724,38 +1845,37 @@
           <a:p>
             <a:pPr lvl="0"/>
             <a:r>
-              <a:rPr lang="en-US" smtClean="0"/>
+              <a:rPr lang="en-US"/>
               <a:t>Click to edit Master text styles</a:t>
             </a:r>
           </a:p>
           <a:p>
             <a:pPr lvl="1"/>
             <a:r>
-              <a:rPr lang="en-US" smtClean="0"/>
+              <a:rPr lang="en-US"/>
               <a:t>Second level</a:t>
             </a:r>
           </a:p>
           <a:p>
             <a:pPr lvl="2"/>
             <a:r>
-              <a:rPr lang="en-US" smtClean="0"/>
+              <a:rPr lang="en-US"/>
               <a:t>Third level</a:t>
             </a:r>
           </a:p>
           <a:p>
             <a:pPr lvl="3"/>
             <a:r>
-              <a:rPr lang="en-US" smtClean="0"/>
+              <a:rPr lang="en-US"/>
               <a:t>Fourth level</a:t>
             </a:r>
           </a:p>
           <a:p>
             <a:pPr lvl="4"/>
             <a:r>
-              <a:rPr lang="en-US" smtClean="0"/>
+              <a:rPr lang="en-US"/>
               <a:t>Fifth level</a:t>
             </a:r>
-            <a:endParaRPr lang="en-US"/>
           </a:p>
         </p:txBody>
       </p:sp>
@@ -1776,7 +1896,7 @@
           <a:p>
             <a:fld id="{5BCAD085-E8A6-8845-BD4E-CB4CCA059FC4}" type="datetimeFigureOut">
               <a:rPr lang="en-US" smtClean="0"/>
-              <a:t>1/27/13</a:t>
+              <a:t>3/14/2026</a:t>
             </a:fld>
             <a:endParaRPr lang="en-US"/>
           </a:p>
@@ -1870,10 +1990,9 @@
           <a:lstStyle/>
           <a:p>
             <a:r>
-              <a:rPr lang="en-US" smtClean="0"/>
+              <a:rPr lang="en-US"/>
               <a:t>Click to edit Master title style</a:t>
             </a:r>
-            <a:endParaRPr lang="en-US"/>
           </a:p>
         </p:txBody>
       </p:sp>
@@ -1894,7 +2013,7 @@
           <a:p>
             <a:fld id="{5BCAD085-E8A6-8845-BD4E-CB4CCA059FC4}" type="datetimeFigureOut">
               <a:rPr lang="en-US" smtClean="0"/>
-              <a:t>1/27/13</a:t>
+              <a:t>3/14/2026</a:t>
             </a:fld>
             <a:endParaRPr lang="en-US"/>
           </a:p>
@@ -1989,7 +2108,7 @@
           <a:p>
             <a:fld id="{5BCAD085-E8A6-8845-BD4E-CB4CCA059FC4}" type="datetimeFigureOut">
               <a:rPr lang="en-US" smtClean="0"/>
-              <a:t>1/27/13</a:t>
+              <a:t>3/14/2026</a:t>
             </a:fld>
             <a:endParaRPr lang="en-US"/>
           </a:p>
@@ -2092,10 +2211,9 @@
           </a:lstStyle>
           <a:p>
             <a:r>
-              <a:rPr lang="en-US" smtClean="0"/>
+              <a:rPr lang="en-US"/>
               <a:t>Click to edit Master title style</a:t>
             </a:r>
-            <a:endParaRPr lang="en-US"/>
           </a:p>
         </p:txBody>
       </p:sp>
@@ -2149,38 +2267,37 @@
           <a:p>
             <a:pPr lvl="0"/>
             <a:r>
-              <a:rPr lang="en-US" smtClean="0"/>
+              <a:rPr lang="en-US"/>
               <a:t>Click to edit Master text styles</a:t>
             </a:r>
           </a:p>
           <a:p>
             <a:pPr lvl="1"/>
             <a:r>
-              <a:rPr lang="en-US" smtClean="0"/>
+              <a:rPr lang="en-US"/>
               <a:t>Second level</a:t>
             </a:r>
           </a:p>
           <a:p>
             <a:pPr lvl="2"/>
             <a:r>
-              <a:rPr lang="en-US" smtClean="0"/>
+              <a:rPr lang="en-US"/>
               <a:t>Third level</a:t>
             </a:r>
           </a:p>
           <a:p>
             <a:pPr lvl="3"/>
             <a:r>
-              <a:rPr lang="en-US" smtClean="0"/>
+              <a:rPr lang="en-US"/>
               <a:t>Fourth level</a:t>
             </a:r>
           </a:p>
           <a:p>
             <a:pPr lvl="4"/>
             <a:r>
-              <a:rPr lang="en-US" smtClean="0"/>
+              <a:rPr lang="en-US"/>
               <a:t>Fifth level</a:t>
             </a:r>
-            <a:endParaRPr lang="en-US"/>
           </a:p>
         </p:txBody>
       </p:sp>
@@ -2243,7 +2360,7 @@
           <a:p>
             <a:pPr lvl="0"/>
             <a:r>
-              <a:rPr lang="en-US" smtClean="0"/>
+              <a:rPr lang="en-US"/>
               <a:t>Click to edit Master text styles</a:t>
             </a:r>
           </a:p>
@@ -2266,7 +2383,7 @@
           <a:p>
             <a:fld id="{5BCAD085-E8A6-8845-BD4E-CB4CCA059FC4}" type="datetimeFigureOut">
               <a:rPr lang="en-US" smtClean="0"/>
-              <a:t>1/27/13</a:t>
+              <a:t>3/14/2026</a:t>
             </a:fld>
             <a:endParaRPr lang="en-US"/>
           </a:p>
@@ -2369,10 +2486,9 @@
           </a:lstStyle>
           <a:p>
             <a:r>
-              <a:rPr lang="en-US" smtClean="0"/>
+              <a:rPr lang="en-US"/>
               <a:t>Click to edit Master title style</a:t>
             </a:r>
-            <a:endParaRPr lang="en-US"/>
           </a:p>
         </p:txBody>
       </p:sp>
@@ -2496,7 +2612,7 @@
           <a:p>
             <a:pPr lvl="0"/>
             <a:r>
-              <a:rPr lang="en-US" smtClean="0"/>
+              <a:rPr lang="en-US"/>
               <a:t>Click to edit Master text styles</a:t>
             </a:r>
           </a:p>
@@ -2519,7 +2635,7 @@
           <a:p>
             <a:fld id="{5BCAD085-E8A6-8845-BD4E-CB4CCA059FC4}" type="datetimeFigureOut">
               <a:rPr lang="en-US" smtClean="0"/>
-              <a:t>1/27/13</a:t>
+              <a:t>3/14/2026</a:t>
             </a:fld>
             <a:endParaRPr lang="en-US"/>
           </a:p>
@@ -2628,10 +2744,9 @@
           <a:lstStyle/>
           <a:p>
             <a:r>
-              <a:rPr lang="en-US" smtClean="0"/>
+              <a:rPr lang="en-US"/>
               <a:t>Click to edit Master title style</a:t>
             </a:r>
-            <a:endParaRPr lang="en-US"/>
           </a:p>
         </p:txBody>
       </p:sp>
@@ -2662,38 +2777,37 @@
           <a:p>
             <a:pPr lvl="0"/>
             <a:r>
-              <a:rPr lang="en-US" smtClean="0"/>
+              <a:rPr lang="en-US"/>
               <a:t>Click to edit Master text styles</a:t>
             </a:r>
           </a:p>
           <a:p>
             <a:pPr lvl="1"/>
             <a:r>
-              <a:rPr lang="en-US" smtClean="0"/>
+              <a:rPr lang="en-US"/>
               <a:t>Second level</a:t>
             </a:r>
           </a:p>
           <a:p>
             <a:pPr lvl="2"/>
             <a:r>
-              <a:rPr lang="en-US" smtClean="0"/>
+              <a:rPr lang="en-US"/>
               <a:t>Third level</a:t>
             </a:r>
           </a:p>
           <a:p>
             <a:pPr lvl="3"/>
             <a:r>
-              <a:rPr lang="en-US" smtClean="0"/>
+              <a:rPr lang="en-US"/>
               <a:t>Fourth level</a:t>
             </a:r>
           </a:p>
           <a:p>
             <a:pPr lvl="4"/>
             <a:r>
-              <a:rPr lang="en-US" smtClean="0"/>
+              <a:rPr lang="en-US"/>
               <a:t>Fifth level</a:t>
             </a:r>
-            <a:endParaRPr lang="en-US"/>
           </a:p>
         </p:txBody>
       </p:sp>
@@ -2732,7 +2846,7 @@
           <a:p>
             <a:fld id="{5BCAD085-E8A6-8845-BD4E-CB4CCA059FC4}" type="datetimeFigureOut">
               <a:rPr lang="en-US" smtClean="0"/>
-              <a:t>1/27/13</a:t>
+              <a:t>3/14/2026</a:t>
             </a:fld>
             <a:endParaRPr lang="en-US"/>
           </a:p>
@@ -3091,7 +3205,7 @@
 </file>
 
 <file path=ppt/slides/slide1.xml><?xml version="1.0" encoding="utf-8"?>
-<p:sld xmlns:a="http://schemas.openxmlformats.org/drawingml/2006/main" xmlns:p="http://schemas.openxmlformats.org/presentationml/2006/main" xmlns:r="http://schemas.openxmlformats.org/officeDocument/2006/relationships">
+<p:sld xmlns:a="http://schemas.openxmlformats.org/drawingml/2006/main" xmlns:r="http://schemas.openxmlformats.org/officeDocument/2006/relationships" xmlns:p="http://schemas.openxmlformats.org/presentationml/2006/main">
   <p:cSld>
     <p:bg>
       <p:bgPr>
@@ -3107,7 +3221,14 @@
         <p:cNvGrpSpPr/>
         <p:nvPr/>
       </p:nvGrpSpPr>
-      <p:grpSpPr/>
+      <p:grpSpPr>
+        <a:xfrm>
+          <a:off x="0" y="0"/>
+          <a:ext cx="0" cy="0"/>
+          <a:chOff x="0" y="0"/>
+          <a:chExt cx="0" cy="0"/>
+        </a:xfrm>
+      </p:grpSpPr>
       <p:sp>
         <p:nvSpPr>
           <p:cNvPr id="2" name="TextBox 1"/>
@@ -3265,7 +3386,7 @@
         <p:spPr>
           <a:xfrm>
             <a:off x="1828800" y="5669280"/>
-            <a:ext cx="8229600" cy="457200"/>
+            <a:ext cx="8229600" cy="707886"/>
           </a:xfrm>
           <a:prstGeom prst="rect">
             <a:avLst/>
@@ -3287,8 +3408,28 @@
               </a:defRPr>
             </a:pPr>
             <a:r>
-              <a:t>Team: Jetash Jethi</a:t>
-            </a:r>
+              <a:rPr dirty="0"/>
+              <a:t>Team: </a:t>
+            </a:r>
+            <a:r>
+              <a:rPr lang="en-IN" sz="2000" b="1" dirty="0"/>
+              <a:t>Aegis </a:t>
+            </a:r>
+          </a:p>
+          <a:p>
+            <a:pPr algn="ctr">
+              <a:defRPr sz="2000" b="1">
+                <a:solidFill>
+                  <a:srgbClr val="FFFFFF"/>
+                </a:solidFill>
+                <a:latin typeface="Calibri"/>
+              </a:defRPr>
+            </a:pPr>
+            <a:r>
+              <a:rPr lang="en-IN" sz="2000" b="1" dirty="0"/>
+              <a:t>Members: Jetash Jethi</a:t>
+            </a:r>
+            <a:endParaRPr dirty="0"/>
           </a:p>
         </p:txBody>
       </p:sp>
@@ -3301,7 +3442,7 @@
 </file>
 
 <file path=ppt/slides/slide10.xml><?xml version="1.0" encoding="utf-8"?>
-<p:sld xmlns:a="http://schemas.openxmlformats.org/drawingml/2006/main" xmlns:p="http://schemas.openxmlformats.org/presentationml/2006/main" xmlns:r="http://schemas.openxmlformats.org/officeDocument/2006/relationships">
+<p:sld xmlns:a="http://schemas.openxmlformats.org/drawingml/2006/main" xmlns:r="http://schemas.openxmlformats.org/officeDocument/2006/relationships" xmlns:p="http://schemas.openxmlformats.org/presentationml/2006/main">
   <p:cSld>
     <p:bg>
       <p:bgPr>
@@ -3317,7 +3458,14 @@
         <p:cNvGrpSpPr/>
         <p:nvPr/>
       </p:nvGrpSpPr>
-      <p:grpSpPr/>
+      <p:grpSpPr>
+        <a:xfrm>
+          <a:off x="0" y="0"/>
+          <a:ext cx="0" cy="0"/>
+          <a:chOff x="0" y="0"/>
+          <a:chExt cx="0" cy="0"/>
+        </a:xfrm>
+      </p:grpSpPr>
       <p:sp>
         <p:nvSpPr>
           <p:cNvPr id="2" name="TextBox 1"/>
@@ -3395,6 +3543,7 @@
           <a:lstStyle/>
           <a:p>
             <a:pPr algn="ctr"/>
+            <a:endParaRPr/>
           </a:p>
         </p:txBody>
       </p:sp>
@@ -3511,6 +3660,7 @@
           <a:lstStyle/>
           <a:p>
             <a:pPr algn="ctr"/>
+            <a:endParaRPr/>
           </a:p>
         </p:txBody>
       </p:sp>
@@ -3627,6 +3777,7 @@
           <a:lstStyle/>
           <a:p>
             <a:pPr algn="ctr"/>
+            <a:endParaRPr/>
           </a:p>
         </p:txBody>
       </p:sp>
@@ -3743,6 +3894,7 @@
           <a:lstStyle/>
           <a:p>
             <a:pPr algn="ctr"/>
+            <a:endParaRPr/>
           </a:p>
         </p:txBody>
       </p:sp>
@@ -3859,6 +4011,7 @@
           <a:lstStyle/>
           <a:p>
             <a:pPr algn="ctr"/>
+            <a:endParaRPr/>
           </a:p>
         </p:txBody>
       </p:sp>
@@ -3943,7 +4096,7 @@
 </file>
 
 <file path=ppt/slides/slide11.xml><?xml version="1.0" encoding="utf-8"?>
-<p:sld xmlns:a="http://schemas.openxmlformats.org/drawingml/2006/main" xmlns:p="http://schemas.openxmlformats.org/presentationml/2006/main" xmlns:r="http://schemas.openxmlformats.org/officeDocument/2006/relationships">
+<p:sld xmlns:a="http://schemas.openxmlformats.org/drawingml/2006/main" xmlns:r="http://schemas.openxmlformats.org/officeDocument/2006/relationships" xmlns:p="http://schemas.openxmlformats.org/presentationml/2006/main">
   <p:cSld>
     <p:bg>
       <p:bgPr>
@@ -3959,7 +4112,14 @@
         <p:cNvGrpSpPr/>
         <p:nvPr/>
       </p:nvGrpSpPr>
-      <p:grpSpPr/>
+      <p:grpSpPr>
+        <a:xfrm>
+          <a:off x="0" y="0"/>
+          <a:ext cx="0" cy="0"/>
+          <a:chOff x="0" y="0"/>
+          <a:chExt cx="0" cy="0"/>
+        </a:xfrm>
+      </p:grpSpPr>
       <p:sp>
         <p:nvSpPr>
           <p:cNvPr id="2" name="TextBox 1"/>
@@ -4037,6 +4197,7 @@
           <a:lstStyle/>
           <a:p>
             <a:pPr algn="ctr"/>
+            <a:endParaRPr/>
           </a:p>
         </p:txBody>
       </p:sp>
@@ -4117,6 +4278,7 @@
           <a:lstStyle/>
           <a:p>
             <a:pPr algn="ctr"/>
+            <a:endParaRPr/>
           </a:p>
         </p:txBody>
       </p:sp>
@@ -4201,6 +4363,7 @@
           <a:lstStyle/>
           <a:p>
             <a:pPr algn="ctr"/>
+            <a:endParaRPr/>
           </a:p>
         </p:txBody>
       </p:sp>
@@ -4281,6 +4444,7 @@
           <a:lstStyle/>
           <a:p>
             <a:pPr algn="ctr"/>
+            <a:endParaRPr/>
           </a:p>
         </p:txBody>
       </p:sp>
@@ -4365,6 +4529,7 @@
           <a:lstStyle/>
           <a:p>
             <a:pPr algn="ctr"/>
+            <a:endParaRPr/>
           </a:p>
         </p:txBody>
       </p:sp>
@@ -4445,6 +4610,7 @@
           <a:lstStyle/>
           <a:p>
             <a:pPr algn="ctr"/>
+            <a:endParaRPr/>
           </a:p>
         </p:txBody>
       </p:sp>
@@ -4529,6 +4695,7 @@
           <a:lstStyle/>
           <a:p>
             <a:pPr algn="ctr"/>
+            <a:endParaRPr/>
           </a:p>
         </p:txBody>
       </p:sp>
@@ -4613,6 +4780,7 @@
           <a:lstStyle/>
           <a:p>
             <a:pPr algn="ctr"/>
+            <a:endParaRPr/>
           </a:p>
         </p:txBody>
       </p:sp>
@@ -4697,6 +4865,7 @@
           <a:lstStyle/>
           <a:p>
             <a:pPr algn="ctr"/>
+            <a:endParaRPr/>
           </a:p>
         </p:txBody>
       </p:sp>
@@ -4777,6 +4946,7 @@
           <a:lstStyle/>
           <a:p>
             <a:pPr algn="ctr"/>
+            <a:endParaRPr/>
           </a:p>
         </p:txBody>
       </p:sp>
@@ -4861,6 +5031,7 @@
           <a:lstStyle/>
           <a:p>
             <a:pPr algn="ctr"/>
+            <a:endParaRPr/>
           </a:p>
         </p:txBody>
       </p:sp>
@@ -4945,6 +5116,7 @@
           <a:lstStyle/>
           <a:p>
             <a:pPr algn="ctr"/>
+            <a:endParaRPr/>
           </a:p>
         </p:txBody>
       </p:sp>
@@ -4997,7 +5169,7 @@
 </file>
 
 <file path=ppt/slides/slide12.xml><?xml version="1.0" encoding="utf-8"?>
-<p:sld xmlns:a="http://schemas.openxmlformats.org/drawingml/2006/main" xmlns:p="http://schemas.openxmlformats.org/presentationml/2006/main" xmlns:r="http://schemas.openxmlformats.org/officeDocument/2006/relationships">
+<p:sld xmlns:a="http://schemas.openxmlformats.org/drawingml/2006/main" xmlns:r="http://schemas.openxmlformats.org/officeDocument/2006/relationships" xmlns:p="http://schemas.openxmlformats.org/presentationml/2006/main">
   <p:cSld>
     <p:bg>
       <p:bgPr>
@@ -5013,7 +5185,14 @@
         <p:cNvGrpSpPr/>
         <p:nvPr/>
       </p:nvGrpSpPr>
-      <p:grpSpPr/>
+      <p:grpSpPr>
+        <a:xfrm>
+          <a:off x="0" y="0"/>
+          <a:ext cx="0" cy="0"/>
+          <a:chOff x="0" y="0"/>
+          <a:chExt cx="0" cy="0"/>
+        </a:xfrm>
+      </p:grpSpPr>
       <p:sp>
         <p:nvSpPr>
           <p:cNvPr id="2" name="TextBox 1"/>
@@ -5091,6 +5270,7 @@
           <a:lstStyle/>
           <a:p>
             <a:pPr algn="ctr"/>
+            <a:endParaRPr/>
           </a:p>
         </p:txBody>
       </p:sp>
@@ -5211,6 +5391,7 @@
           <a:lstStyle/>
           <a:p>
             <a:pPr algn="ctr"/>
+            <a:endParaRPr/>
           </a:p>
         </p:txBody>
       </p:sp>
@@ -5331,6 +5512,7 @@
           <a:lstStyle/>
           <a:p>
             <a:pPr algn="ctr"/>
+            <a:endParaRPr/>
           </a:p>
         </p:txBody>
       </p:sp>
@@ -5451,6 +5633,7 @@
           <a:lstStyle/>
           <a:p>
             <a:pPr algn="ctr"/>
+            <a:endParaRPr/>
           </a:p>
         </p:txBody>
       </p:sp>
@@ -5571,6 +5754,7 @@
           <a:lstStyle/>
           <a:p>
             <a:pPr algn="ctr"/>
+            <a:endParaRPr/>
           </a:p>
         </p:txBody>
       </p:sp>
@@ -5691,6 +5875,7 @@
           <a:lstStyle/>
           <a:p>
             <a:pPr algn="ctr"/>
+            <a:endParaRPr/>
           </a:p>
         </p:txBody>
       </p:sp>
@@ -5779,7 +5964,7 @@
 </file>
 
 <file path=ppt/slides/slide13.xml><?xml version="1.0" encoding="utf-8"?>
-<p:sld xmlns:a="http://schemas.openxmlformats.org/drawingml/2006/main" xmlns:p="http://schemas.openxmlformats.org/presentationml/2006/main" xmlns:r="http://schemas.openxmlformats.org/officeDocument/2006/relationships">
+<p:sld xmlns:a="http://schemas.openxmlformats.org/drawingml/2006/main" xmlns:r="http://schemas.openxmlformats.org/officeDocument/2006/relationships" xmlns:p="http://schemas.openxmlformats.org/presentationml/2006/main">
   <p:cSld>
     <p:bg>
       <p:bgPr>
@@ -5795,163 +5980,14 @@
         <p:cNvGrpSpPr/>
         <p:nvPr/>
       </p:nvGrpSpPr>
-      <p:grpSpPr/>
-      <p:sp>
-        <p:nvSpPr>
-          <p:cNvPr id="2" name="TextBox 1"/>
-          <p:cNvSpPr txBox="1"/>
-          <p:nvPr/>
-        </p:nvSpPr>
-        <p:spPr>
-          <a:xfrm>
-            <a:off x="457200" y="1371600"/>
-            <a:ext cx="10972800" cy="914400"/>
-          </a:xfrm>
-          <a:prstGeom prst="rect">
-            <a:avLst/>
-          </a:prstGeom>
-          <a:noFill/>
-        </p:spPr>
-        <p:txBody>
-          <a:bodyPr wrap="square">
-            <a:spAutoFit/>
-          </a:bodyPr>
-          <a:lstStyle/>
-          <a:p>
-            <a:pPr algn="ctr">
-              <a:defRPr sz="5000" b="1">
-                <a:solidFill>
-                  <a:srgbClr val="10B9FF"/>
-                </a:solidFill>
-                <a:latin typeface="Calibri"/>
-              </a:defRPr>
-            </a:pPr>
-            <a:r>
-              <a:t>Live Demo</a:t>
-            </a:r>
-          </a:p>
-        </p:txBody>
-      </p:sp>
-      <p:sp>
-        <p:nvSpPr>
-          <p:cNvPr id="3" name="Rounded Rectangle 2"/>
-          <p:cNvSpPr/>
-          <p:nvPr/>
-        </p:nvSpPr>
-        <p:spPr>
-          <a:xfrm>
-            <a:off x="3200400" y="2743200"/>
-            <a:ext cx="5760720" cy="731520"/>
-          </a:xfrm>
-          <a:prstGeom prst="roundRect">
-            <a:avLst/>
-          </a:prstGeom>
-          <a:solidFill>
-            <a:srgbClr val="0A2A1A"/>
-          </a:solidFill>
-          <a:ln>
-            <a:noFill/>
-          </a:ln>
-          <a:effectLst/>
-        </p:spPr>
-        <p:style>
-          <a:lnRef idx="1">
-            <a:schemeClr val="accent1"/>
-          </a:lnRef>
-          <a:fillRef idx="3">
-            <a:schemeClr val="accent1"/>
-          </a:fillRef>
-          <a:effectRef idx="2">
-            <a:schemeClr val="accent1"/>
-          </a:effectRef>
-          <a:fontRef idx="minor">
-            <a:schemeClr val="lt1"/>
-          </a:fontRef>
-        </p:style>
-        <p:txBody>
-          <a:bodyPr rtlCol="0" anchor="ctr"/>
-          <a:lstStyle/>
-          <a:p>
-            <a:pPr algn="ctr"/>
-          </a:p>
-        </p:txBody>
-      </p:sp>
-      <p:sp>
-        <p:nvSpPr>
-          <p:cNvPr id="4" name="TextBox 3"/>
-          <p:cNvSpPr txBox="1"/>
-          <p:nvPr/>
-        </p:nvSpPr>
-        <p:spPr>
-          <a:xfrm>
-            <a:off x="3474720" y="2834640"/>
-            <a:ext cx="5303520" cy="548640"/>
-          </a:xfrm>
-          <a:prstGeom prst="rect">
-            <a:avLst/>
-          </a:prstGeom>
-          <a:noFill/>
-        </p:spPr>
-        <p:txBody>
-          <a:bodyPr wrap="square">
-            <a:spAutoFit/>
-          </a:bodyPr>
-          <a:lstStyle/>
-          <a:p>
-            <a:pPr algn="ctr">
-              <a:defRPr sz="2600" b="1">
-                <a:solidFill>
-                  <a:srgbClr val="06D6A0"/>
-                </a:solidFill>
-                <a:latin typeface="Calibri"/>
-              </a:defRPr>
-            </a:pPr>
-            <a:r>
-              <a:t>streamlit run dashboard.py</a:t>
-            </a:r>
-          </a:p>
-        </p:txBody>
-      </p:sp>
-      <p:sp>
-        <p:nvSpPr>
-          <p:cNvPr id="5" name="TextBox 4"/>
-          <p:cNvSpPr txBox="1"/>
-          <p:nvPr/>
-        </p:nvSpPr>
-        <p:spPr>
-          <a:xfrm>
-            <a:off x="1828800" y="3840480"/>
-            <a:ext cx="8229600" cy="731520"/>
-          </a:xfrm>
-          <a:prstGeom prst="rect">
-            <a:avLst/>
-          </a:prstGeom>
-          <a:noFill/>
-        </p:spPr>
-        <p:txBody>
-          <a:bodyPr wrap="square">
-            <a:spAutoFit/>
-          </a:bodyPr>
-          <a:lstStyle/>
-          <a:p>
-            <a:pPr algn="ctr">
-              <a:defRPr sz="1700" b="0">
-                <a:solidFill>
-                  <a:srgbClr val="94A3B8"/>
-                </a:solidFill>
-                <a:latin typeface="Calibri"/>
-              </a:defRPr>
-            </a:pPr>
-            <a:r>
-              <a:t>Interactive fraud detection with real-time risk scoring,</a:t>
-            </a:r>
-            <a:br/>
-            <a:r>
-              <a:t>explainable AI, and adaptive authentication</a:t>
-            </a:r>
-          </a:p>
-        </p:txBody>
-      </p:sp>
+      <p:grpSpPr>
+        <a:xfrm>
+          <a:off x="0" y="0"/>
+          <a:ext cx="0" cy="0"/>
+          <a:chOff x="0" y="0"/>
+          <a:chExt cx="0" cy="0"/>
+        </a:xfrm>
+      </p:grpSpPr>
       <p:sp>
         <p:nvSpPr>
           <p:cNvPr id="6" name="TextBox 5"/>
@@ -5960,7 +5996,7 @@
         </p:nvSpPr>
         <p:spPr>
           <a:xfrm>
-            <a:off x="457200" y="5029200"/>
+            <a:off x="609600" y="3063240"/>
             <a:ext cx="10972800" cy="731520"/>
           </a:xfrm>
           <a:prstGeom prst="rect">
@@ -5983,6 +6019,7 @@
               </a:defRPr>
             </a:pPr>
             <a:r>
+              <a:rPr dirty="0"/>
               <a:t>Thank You!</a:t>
             </a:r>
           </a:p>
@@ -5996,7 +6033,7 @@
         </p:nvSpPr>
         <p:spPr>
           <a:xfrm>
-            <a:off x="1828800" y="5852160"/>
+            <a:off x="1981200" y="6417515"/>
             <a:ext cx="8229600" cy="365760"/>
           </a:xfrm>
           <a:prstGeom prst="rect">
@@ -6019,7 +6056,24 @@
               </a:defRPr>
             </a:pPr>
             <a:r>
-              <a:t>github.com/jetashjethi-ui/FraudShield-AI</a:t>
+              <a:rPr dirty="0"/>
+              <a:t>github.com/</a:t>
+            </a:r>
+            <a:r>
+              <a:rPr dirty="0" err="1"/>
+              <a:t>jetashjethi-ui</a:t>
+            </a:r>
+            <a:r>
+              <a:rPr dirty="0"/>
+              <a:t>/</a:t>
+            </a:r>
+            <a:r>
+              <a:rPr dirty="0" err="1"/>
+              <a:t>FraudShield</a:t>
+            </a:r>
+            <a:r>
+              <a:rPr dirty="0"/>
+              <a:t>-AI</a:t>
             </a:r>
           </a:p>
         </p:txBody>
@@ -6033,7 +6087,7 @@
 </file>
 
 <file path=ppt/slides/slide2.xml><?xml version="1.0" encoding="utf-8"?>
-<p:sld xmlns:a="http://schemas.openxmlformats.org/drawingml/2006/main" xmlns:p="http://schemas.openxmlformats.org/presentationml/2006/main" xmlns:r="http://schemas.openxmlformats.org/officeDocument/2006/relationships">
+<p:sld xmlns:a="http://schemas.openxmlformats.org/drawingml/2006/main" xmlns:r="http://schemas.openxmlformats.org/officeDocument/2006/relationships" xmlns:p="http://schemas.openxmlformats.org/presentationml/2006/main">
   <p:cSld>
     <p:bg>
       <p:bgPr>
@@ -6049,7 +6103,14 @@
         <p:cNvGrpSpPr/>
         <p:nvPr/>
       </p:nvGrpSpPr>
-      <p:grpSpPr/>
+      <p:grpSpPr>
+        <a:xfrm>
+          <a:off x="0" y="0"/>
+          <a:ext cx="0" cy="0"/>
+          <a:chOff x="0" y="0"/>
+          <a:chExt cx="0" cy="0"/>
+        </a:xfrm>
+      </p:grpSpPr>
       <p:sp>
         <p:nvSpPr>
           <p:cNvPr id="2" name="TextBox 1"/>
@@ -6127,6 +6188,7 @@
           <a:lstStyle/>
           <a:p>
             <a:pPr algn="ctr"/>
+            <a:endParaRPr/>
           </a:p>
         </p:txBody>
       </p:sp>
@@ -6247,6 +6309,7 @@
           <a:lstStyle/>
           <a:p>
             <a:pPr algn="ctr"/>
+            <a:endParaRPr/>
           </a:p>
         </p:txBody>
       </p:sp>
@@ -6367,6 +6430,7 @@
           <a:lstStyle/>
           <a:p>
             <a:pPr algn="ctr"/>
+            <a:endParaRPr/>
           </a:p>
         </p:txBody>
       </p:sp>
@@ -6487,6 +6551,7 @@
           <a:lstStyle/>
           <a:p>
             <a:pPr algn="ctr"/>
+            <a:endParaRPr/>
           </a:p>
         </p:txBody>
       </p:sp>
@@ -6612,6 +6677,7 @@
                 <a:latin typeface="Calibri"/>
               </a:defRPr>
             </a:pPr>
+            <a:endParaRPr/>
           </a:p>
           <a:p>
             <a:pPr>
@@ -6688,7 +6754,7 @@
 </file>
 
 <file path=ppt/slides/slide3.xml><?xml version="1.0" encoding="utf-8"?>
-<p:sld xmlns:a="http://schemas.openxmlformats.org/drawingml/2006/main" xmlns:p="http://schemas.openxmlformats.org/presentationml/2006/main" xmlns:r="http://schemas.openxmlformats.org/officeDocument/2006/relationships">
+<p:sld xmlns:a="http://schemas.openxmlformats.org/drawingml/2006/main" xmlns:r="http://schemas.openxmlformats.org/officeDocument/2006/relationships" xmlns:p="http://schemas.openxmlformats.org/presentationml/2006/main">
   <p:cSld>
     <p:bg>
       <p:bgPr>
@@ -6704,7 +6770,14 @@
         <p:cNvGrpSpPr/>
         <p:nvPr/>
       </p:nvGrpSpPr>
-      <p:grpSpPr/>
+      <p:grpSpPr>
+        <a:xfrm>
+          <a:off x="0" y="0"/>
+          <a:ext cx="0" cy="0"/>
+          <a:chOff x="0" y="0"/>
+          <a:chExt cx="0" cy="0"/>
+        </a:xfrm>
+      </p:grpSpPr>
       <p:sp>
         <p:nvSpPr>
           <p:cNvPr id="2" name="TextBox 1"/>
@@ -6818,6 +6891,7 @@
           <a:lstStyle/>
           <a:p>
             <a:pPr algn="ctr"/>
+            <a:endParaRPr/>
           </a:p>
         </p:txBody>
       </p:sp>
@@ -6934,6 +7008,7 @@
           <a:lstStyle/>
           <a:p>
             <a:pPr algn="ctr"/>
+            <a:endParaRPr/>
           </a:p>
         </p:txBody>
       </p:sp>
@@ -7050,6 +7125,7 @@
           <a:lstStyle/>
           <a:p>
             <a:pPr algn="ctr"/>
+            <a:endParaRPr/>
           </a:p>
         </p:txBody>
       </p:sp>
@@ -7166,6 +7242,7 @@
           <a:lstStyle/>
           <a:p>
             <a:pPr algn="ctr"/>
+            <a:endParaRPr/>
           </a:p>
         </p:txBody>
       </p:sp>
@@ -7250,7 +7327,7 @@
 </file>
 
 <file path=ppt/slides/slide4.xml><?xml version="1.0" encoding="utf-8"?>
-<p:sld xmlns:a="http://schemas.openxmlformats.org/drawingml/2006/main" xmlns:p="http://schemas.openxmlformats.org/presentationml/2006/main" xmlns:r="http://schemas.openxmlformats.org/officeDocument/2006/relationships">
+<p:sld xmlns:a="http://schemas.openxmlformats.org/drawingml/2006/main" xmlns:r="http://schemas.openxmlformats.org/officeDocument/2006/relationships" xmlns:p="http://schemas.openxmlformats.org/presentationml/2006/main">
   <p:cSld>
     <p:bg>
       <p:bgPr>
@@ -7266,7 +7343,14 @@
         <p:cNvGrpSpPr/>
         <p:nvPr/>
       </p:nvGrpSpPr>
-      <p:grpSpPr/>
+      <p:grpSpPr>
+        <a:xfrm>
+          <a:off x="0" y="0"/>
+          <a:ext cx="0" cy="0"/>
+          <a:chOff x="0" y="0"/>
+          <a:chExt cx="0" cy="0"/>
+        </a:xfrm>
+      </p:grpSpPr>
       <p:sp>
         <p:nvSpPr>
           <p:cNvPr id="2" name="TextBox 1"/>
@@ -7344,6 +7428,7 @@
           <a:lstStyle/>
           <a:p>
             <a:pPr algn="ctr"/>
+            <a:endParaRPr/>
           </a:p>
         </p:txBody>
       </p:sp>
@@ -7496,6 +7581,7 @@
           <a:lstStyle/>
           <a:p>
             <a:pPr algn="ctr"/>
+            <a:endParaRPr/>
           </a:p>
         </p:txBody>
       </p:sp>
@@ -7648,6 +7734,7 @@
           <a:lstStyle/>
           <a:p>
             <a:pPr algn="ctr"/>
+            <a:endParaRPr/>
           </a:p>
         </p:txBody>
       </p:sp>
@@ -7800,6 +7887,7 @@
           <a:lstStyle/>
           <a:p>
             <a:pPr algn="ctr"/>
+            <a:endParaRPr/>
           </a:p>
         </p:txBody>
       </p:sp>
@@ -7916,6 +8004,7 @@
           <a:lstStyle/>
           <a:p>
             <a:pPr algn="ctr"/>
+            <a:endParaRPr/>
           </a:p>
         </p:txBody>
       </p:sp>
@@ -7985,6 +8074,7 @@
                 <a:latin typeface="Calibri"/>
               </a:defRPr>
             </a:pPr>
+            <a:endParaRPr/>
           </a:p>
           <a:p>
             <a:pPr>
@@ -8109,7 +8199,7 @@
 </file>
 
 <file path=ppt/slides/slide5.xml><?xml version="1.0" encoding="utf-8"?>
-<p:sld xmlns:a="http://schemas.openxmlformats.org/drawingml/2006/main" xmlns:p="http://schemas.openxmlformats.org/presentationml/2006/main" xmlns:r="http://schemas.openxmlformats.org/officeDocument/2006/relationships">
+<p:sld xmlns:a="http://schemas.openxmlformats.org/drawingml/2006/main" xmlns:r="http://schemas.openxmlformats.org/officeDocument/2006/relationships" xmlns:p="http://schemas.openxmlformats.org/presentationml/2006/main">
   <p:cSld>
     <p:bg>
       <p:bgPr>
@@ -8125,7 +8215,14 @@
         <p:cNvGrpSpPr/>
         <p:nvPr/>
       </p:nvGrpSpPr>
-      <p:grpSpPr/>
+      <p:grpSpPr>
+        <a:xfrm>
+          <a:off x="0" y="0"/>
+          <a:ext cx="0" cy="0"/>
+          <a:chOff x="0" y="0"/>
+          <a:chExt cx="0" cy="0"/>
+        </a:xfrm>
+      </p:grpSpPr>
       <p:sp>
         <p:nvSpPr>
           <p:cNvPr id="2" name="TextBox 1"/>
@@ -8203,6 +8300,7 @@
           <a:lstStyle/>
           <a:p>
             <a:pPr algn="ctr"/>
+            <a:endParaRPr/>
           </a:p>
         </p:txBody>
       </p:sp>
@@ -8319,6 +8417,7 @@
           <a:lstStyle/>
           <a:p>
             <a:pPr algn="ctr"/>
+            <a:endParaRPr/>
           </a:p>
         </p:txBody>
       </p:sp>
@@ -8435,6 +8534,7 @@
           <a:lstStyle/>
           <a:p>
             <a:pPr algn="ctr"/>
+            <a:endParaRPr/>
           </a:p>
         </p:txBody>
       </p:sp>
@@ -8551,6 +8651,7 @@
           <a:lstStyle/>
           <a:p>
             <a:pPr algn="ctr"/>
+            <a:endParaRPr/>
           </a:p>
         </p:txBody>
       </p:sp>
@@ -8667,6 +8768,7 @@
           <a:lstStyle/>
           <a:p>
             <a:pPr algn="ctr"/>
+            <a:endParaRPr/>
           </a:p>
         </p:txBody>
       </p:sp>
@@ -8783,6 +8885,7 @@
           <a:lstStyle/>
           <a:p>
             <a:pPr algn="ctr"/>
+            <a:endParaRPr/>
           </a:p>
         </p:txBody>
       </p:sp>
@@ -8899,6 +9002,7 @@
           <a:lstStyle/>
           <a:p>
             <a:pPr algn="ctr"/>
+            <a:endParaRPr/>
           </a:p>
         </p:txBody>
       </p:sp>
@@ -9015,6 +9119,7 @@
           <a:lstStyle/>
           <a:p>
             <a:pPr algn="ctr"/>
+            <a:endParaRPr/>
           </a:p>
         </p:txBody>
       </p:sp>
@@ -9131,6 +9236,7 @@
           <a:lstStyle/>
           <a:p>
             <a:pPr algn="ctr"/>
+            <a:endParaRPr/>
           </a:p>
         </p:txBody>
       </p:sp>
@@ -9247,6 +9353,7 @@
           <a:lstStyle/>
           <a:p>
             <a:pPr algn="ctr"/>
+            <a:endParaRPr/>
           </a:p>
         </p:txBody>
       </p:sp>
@@ -9363,6 +9470,7 @@
           <a:lstStyle/>
           <a:p>
             <a:pPr algn="ctr"/>
+            <a:endParaRPr/>
           </a:p>
         </p:txBody>
       </p:sp>
@@ -9479,6 +9587,7 @@
           <a:lstStyle/>
           <a:p>
             <a:pPr algn="ctr"/>
+            <a:endParaRPr/>
           </a:p>
         </p:txBody>
       </p:sp>
@@ -9595,6 +9704,7 @@
           <a:lstStyle/>
           <a:p>
             <a:pPr algn="ctr"/>
+            <a:endParaRPr/>
           </a:p>
         </p:txBody>
       </p:sp>
@@ -9711,6 +9821,7 @@
           <a:lstStyle/>
           <a:p>
             <a:pPr algn="ctr"/>
+            <a:endParaRPr/>
           </a:p>
         </p:txBody>
       </p:sp>
@@ -9827,6 +9938,7 @@
           <a:lstStyle/>
           <a:p>
             <a:pPr algn="ctr"/>
+            <a:endParaRPr/>
           </a:p>
         </p:txBody>
       </p:sp>
@@ -9911,7 +10023,7 @@
 </file>
 
 <file path=ppt/slides/slide6.xml><?xml version="1.0" encoding="utf-8"?>
-<p:sld xmlns:a="http://schemas.openxmlformats.org/drawingml/2006/main" xmlns:p="http://schemas.openxmlformats.org/presentationml/2006/main" xmlns:r="http://schemas.openxmlformats.org/officeDocument/2006/relationships">
+<p:sld xmlns:a="http://schemas.openxmlformats.org/drawingml/2006/main" xmlns:r="http://schemas.openxmlformats.org/officeDocument/2006/relationships" xmlns:p="http://schemas.openxmlformats.org/presentationml/2006/main">
   <p:cSld>
     <p:bg>
       <p:bgPr>
@@ -9927,7 +10039,14 @@
         <p:cNvGrpSpPr/>
         <p:nvPr/>
       </p:nvGrpSpPr>
-      <p:grpSpPr/>
+      <p:grpSpPr>
+        <a:xfrm>
+          <a:off x="0" y="0"/>
+          <a:ext cx="0" cy="0"/>
+          <a:chOff x="0" y="0"/>
+          <a:chExt cx="0" cy="0"/>
+        </a:xfrm>
+      </p:grpSpPr>
       <p:sp>
         <p:nvSpPr>
           <p:cNvPr id="2" name="TextBox 1"/>
@@ -10041,6 +10160,7 @@
           <a:lstStyle/>
           <a:p>
             <a:pPr algn="ctr"/>
+            <a:endParaRPr/>
           </a:p>
         </p:txBody>
       </p:sp>
@@ -10121,6 +10241,7 @@
           <a:lstStyle/>
           <a:p>
             <a:pPr algn="ctr"/>
+            <a:endParaRPr/>
           </a:p>
         </p:txBody>
       </p:sp>
@@ -10201,6 +10322,7 @@
           <a:lstStyle/>
           <a:p>
             <a:pPr algn="ctr"/>
+            <a:endParaRPr/>
           </a:p>
         </p:txBody>
       </p:sp>
@@ -10281,6 +10403,7 @@
           <a:lstStyle/>
           <a:p>
             <a:pPr algn="ctr"/>
+            <a:endParaRPr/>
           </a:p>
         </p:txBody>
       </p:sp>
@@ -10361,6 +10484,7 @@
           <a:lstStyle/>
           <a:p>
             <a:pPr algn="ctr"/>
+            <a:endParaRPr/>
           </a:p>
         </p:txBody>
       </p:sp>
@@ -10441,6 +10565,7 @@
           <a:lstStyle/>
           <a:p>
             <a:pPr algn="ctr"/>
+            <a:endParaRPr/>
           </a:p>
         </p:txBody>
       </p:sp>
@@ -10521,6 +10646,7 @@
           <a:lstStyle/>
           <a:p>
             <a:pPr algn="ctr"/>
+            <a:endParaRPr/>
           </a:p>
         </p:txBody>
       </p:sp>
@@ -10601,6 +10727,7 @@
           <a:lstStyle/>
           <a:p>
             <a:pPr algn="ctr"/>
+            <a:endParaRPr/>
           </a:p>
         </p:txBody>
       </p:sp>
@@ -10681,6 +10808,7 @@
           <a:lstStyle/>
           <a:p>
             <a:pPr algn="ctr"/>
+            <a:endParaRPr/>
           </a:p>
         </p:txBody>
       </p:sp>
@@ -10761,6 +10889,7 @@
           <a:lstStyle/>
           <a:p>
             <a:pPr algn="ctr"/>
+            <a:endParaRPr/>
           </a:p>
         </p:txBody>
       </p:sp>
@@ -10841,6 +10970,7 @@
           <a:lstStyle/>
           <a:p>
             <a:pPr algn="ctr"/>
+            <a:endParaRPr/>
           </a:p>
         </p:txBody>
       </p:sp>
@@ -10921,6 +11051,7 @@
           <a:lstStyle/>
           <a:p>
             <a:pPr algn="ctr"/>
+            <a:endParaRPr/>
           </a:p>
         </p:txBody>
       </p:sp>
@@ -11001,6 +11132,7 @@
           <a:lstStyle/>
           <a:p>
             <a:pPr algn="ctr"/>
+            <a:endParaRPr/>
           </a:p>
         </p:txBody>
       </p:sp>
@@ -11081,6 +11213,7 @@
           <a:lstStyle/>
           <a:p>
             <a:pPr algn="ctr"/>
+            <a:endParaRPr/>
           </a:p>
         </p:txBody>
       </p:sp>
@@ -11161,6 +11294,7 @@
           <a:lstStyle/>
           <a:p>
             <a:pPr algn="ctr"/>
+            <a:endParaRPr/>
           </a:p>
         </p:txBody>
       </p:sp>
@@ -11241,6 +11375,7 @@
           <a:lstStyle/>
           <a:p>
             <a:pPr algn="ctr"/>
+            <a:endParaRPr/>
           </a:p>
         </p:txBody>
       </p:sp>
@@ -11321,6 +11456,7 @@
           <a:lstStyle/>
           <a:p>
             <a:pPr algn="ctr"/>
+            <a:endParaRPr/>
           </a:p>
         </p:txBody>
       </p:sp>
@@ -11401,6 +11537,7 @@
           <a:lstStyle/>
           <a:p>
             <a:pPr algn="ctr"/>
+            <a:endParaRPr/>
           </a:p>
         </p:txBody>
       </p:sp>
@@ -11481,6 +11618,7 @@
           <a:lstStyle/>
           <a:p>
             <a:pPr algn="ctr"/>
+            <a:endParaRPr/>
           </a:p>
         </p:txBody>
       </p:sp>
@@ -11561,6 +11699,7 @@
           <a:lstStyle/>
           <a:p>
             <a:pPr algn="ctr"/>
+            <a:endParaRPr/>
           </a:p>
         </p:txBody>
       </p:sp>
@@ -11641,6 +11780,7 @@
           <a:lstStyle/>
           <a:p>
             <a:pPr algn="ctr"/>
+            <a:endParaRPr/>
           </a:p>
         </p:txBody>
       </p:sp>
@@ -11721,6 +11861,7 @@
           <a:lstStyle/>
           <a:p>
             <a:pPr algn="ctr"/>
+            <a:endParaRPr/>
           </a:p>
         </p:txBody>
       </p:sp>
@@ -11801,6 +11942,7 @@
           <a:lstStyle/>
           <a:p>
             <a:pPr algn="ctr"/>
+            <a:endParaRPr/>
           </a:p>
         </p:txBody>
       </p:sp>
@@ -11881,6 +12023,7 @@
           <a:lstStyle/>
           <a:p>
             <a:pPr algn="ctr"/>
+            <a:endParaRPr/>
           </a:p>
         </p:txBody>
       </p:sp>
@@ -11961,6 +12104,7 @@
           <a:lstStyle/>
           <a:p>
             <a:pPr algn="ctr"/>
+            <a:endParaRPr/>
           </a:p>
         </p:txBody>
       </p:sp>
@@ -12041,6 +12185,7 @@
           <a:lstStyle/>
           <a:p>
             <a:pPr algn="ctr"/>
+            <a:endParaRPr/>
           </a:p>
         </p:txBody>
       </p:sp>
@@ -12121,6 +12266,7 @@
           <a:lstStyle/>
           <a:p>
             <a:pPr algn="ctr"/>
+            <a:endParaRPr/>
           </a:p>
         </p:txBody>
       </p:sp>
@@ -12201,6 +12347,7 @@
           <a:lstStyle/>
           <a:p>
             <a:pPr algn="ctr"/>
+            <a:endParaRPr/>
           </a:p>
         </p:txBody>
       </p:sp>
@@ -12281,6 +12428,7 @@
           <a:lstStyle/>
           <a:p>
             <a:pPr algn="ctr"/>
+            <a:endParaRPr/>
           </a:p>
         </p:txBody>
       </p:sp>
@@ -12361,6 +12509,7 @@
           <a:lstStyle/>
           <a:p>
             <a:pPr algn="ctr"/>
+            <a:endParaRPr/>
           </a:p>
         </p:txBody>
       </p:sp>
@@ -12441,6 +12590,7 @@
           <a:lstStyle/>
           <a:p>
             <a:pPr algn="ctr"/>
+            <a:endParaRPr/>
           </a:p>
         </p:txBody>
       </p:sp>
@@ -12521,6 +12671,7 @@
           <a:lstStyle/>
           <a:p>
             <a:pPr algn="ctr"/>
+            <a:endParaRPr/>
           </a:p>
         </p:txBody>
       </p:sp>
@@ -12601,6 +12752,7 @@
           <a:lstStyle/>
           <a:p>
             <a:pPr algn="ctr"/>
+            <a:endParaRPr/>
           </a:p>
         </p:txBody>
       </p:sp>
@@ -12681,6 +12833,7 @@
           <a:lstStyle/>
           <a:p>
             <a:pPr algn="ctr"/>
+            <a:endParaRPr/>
           </a:p>
         </p:txBody>
       </p:sp>
@@ -12761,6 +12914,7 @@
           <a:lstStyle/>
           <a:p>
             <a:pPr algn="ctr"/>
+            <a:endParaRPr/>
           </a:p>
         </p:txBody>
       </p:sp>
@@ -12808,7 +12962,7 @@
         </p:nvSpPr>
         <p:spPr>
           <a:xfrm>
-            <a:off x="731520" y="5760720"/>
+            <a:off x="731520" y="5919277"/>
             <a:ext cx="10058400" cy="640080"/>
           </a:xfrm>
           <a:prstGeom prst="roundRect">
@@ -12841,6 +12995,7 @@
           <a:lstStyle/>
           <a:p>
             <a:pPr algn="ctr"/>
+            <a:endParaRPr/>
           </a:p>
         </p:txBody>
       </p:sp>
@@ -12852,8 +13007,8 @@
         </p:nvSpPr>
         <p:spPr>
           <a:xfrm>
-            <a:off x="1097280" y="5852160"/>
-            <a:ext cx="9601200" cy="457200"/>
+            <a:off x="795151" y="6035040"/>
+            <a:ext cx="9601200" cy="338554"/>
           </a:xfrm>
           <a:prstGeom prst="rect">
             <a:avLst/>
@@ -12875,6 +13030,7 @@
               </a:defRPr>
             </a:pPr>
             <a:r>
+              <a:rPr dirty="0"/>
               <a:t>Ensemble: AUC 0.937  |  Catches 60.4% of fraud  |  Only 0.7% false alarm rate  |  Auto-tuned threshold</a:t>
             </a:r>
           </a:p>
@@ -12889,7 +13045,7 @@
 </file>
 
 <file path=ppt/slides/slide7.xml><?xml version="1.0" encoding="utf-8"?>
-<p:sld xmlns:a="http://schemas.openxmlformats.org/drawingml/2006/main" xmlns:p="http://schemas.openxmlformats.org/presentationml/2006/main" xmlns:r="http://schemas.openxmlformats.org/officeDocument/2006/relationships">
+<p:sld xmlns:a="http://schemas.openxmlformats.org/drawingml/2006/main" xmlns:r="http://schemas.openxmlformats.org/officeDocument/2006/relationships" xmlns:p="http://schemas.openxmlformats.org/presentationml/2006/main">
   <p:cSld>
     <p:bg>
       <p:bgPr>
@@ -12905,7 +13061,14 @@
         <p:cNvGrpSpPr/>
         <p:nvPr/>
       </p:nvGrpSpPr>
-      <p:grpSpPr/>
+      <p:grpSpPr>
+        <a:xfrm>
+          <a:off x="0" y="0"/>
+          <a:ext cx="0" cy="0"/>
+          <a:chOff x="0" y="0"/>
+          <a:chExt cx="0" cy="0"/>
+        </a:xfrm>
+      </p:grpSpPr>
       <p:sp>
         <p:nvSpPr>
           <p:cNvPr id="2" name="TextBox 1"/>
@@ -12983,6 +13146,7 @@
           <a:lstStyle/>
           <a:p>
             <a:pPr algn="ctr"/>
+            <a:endParaRPr/>
           </a:p>
         </p:txBody>
       </p:sp>
@@ -13459,6 +13623,7 @@
           <a:lstStyle/>
           <a:p>
             <a:pPr algn="ctr"/>
+            <a:endParaRPr/>
           </a:p>
         </p:txBody>
       </p:sp>
@@ -14067,7 +14232,7 @@
 </file>
 
 <file path=ppt/slides/slide8.xml><?xml version="1.0" encoding="utf-8"?>
-<p:sld xmlns:a="http://schemas.openxmlformats.org/drawingml/2006/main" xmlns:p="http://schemas.openxmlformats.org/presentationml/2006/main" xmlns:r="http://schemas.openxmlformats.org/officeDocument/2006/relationships">
+<p:sld xmlns:a="http://schemas.openxmlformats.org/drawingml/2006/main" xmlns:r="http://schemas.openxmlformats.org/officeDocument/2006/relationships" xmlns:p="http://schemas.openxmlformats.org/presentationml/2006/main">
   <p:cSld>
     <p:bg>
       <p:bgPr>
@@ -14083,7 +14248,14 @@
         <p:cNvGrpSpPr/>
         <p:nvPr/>
       </p:nvGrpSpPr>
-      <p:grpSpPr/>
+      <p:grpSpPr>
+        <a:xfrm>
+          <a:off x="0" y="0"/>
+          <a:ext cx="0" cy="0"/>
+          <a:chOff x="0" y="0"/>
+          <a:chExt cx="0" cy="0"/>
+        </a:xfrm>
+      </p:grpSpPr>
       <p:sp>
         <p:nvSpPr>
           <p:cNvPr id="2" name="TextBox 1"/>
@@ -14197,6 +14369,7 @@
           <a:lstStyle/>
           <a:p>
             <a:pPr algn="ctr"/>
+            <a:endParaRPr/>
           </a:p>
         </p:txBody>
       </p:sp>
@@ -14385,6 +14558,7 @@
           <a:lstStyle/>
           <a:p>
             <a:pPr algn="ctr"/>
+            <a:endParaRPr/>
           </a:p>
         </p:txBody>
       </p:sp>
@@ -14573,6 +14747,7 @@
           <a:lstStyle/>
           <a:p>
             <a:pPr algn="ctr"/>
+            <a:endParaRPr/>
           </a:p>
         </p:txBody>
       </p:sp>
@@ -14761,6 +14936,7 @@
           <a:lstStyle/>
           <a:p>
             <a:pPr algn="ctr"/>
+            <a:endParaRPr/>
           </a:p>
         </p:txBody>
       </p:sp>
@@ -14917,7 +15093,7 @@
 </file>
 
 <file path=ppt/slides/slide9.xml><?xml version="1.0" encoding="utf-8"?>
-<p:sld xmlns:a="http://schemas.openxmlformats.org/drawingml/2006/main" xmlns:p="http://schemas.openxmlformats.org/presentationml/2006/main" xmlns:r="http://schemas.openxmlformats.org/officeDocument/2006/relationships">
+<p:sld xmlns:a="http://schemas.openxmlformats.org/drawingml/2006/main" xmlns:r="http://schemas.openxmlformats.org/officeDocument/2006/relationships" xmlns:p="http://schemas.openxmlformats.org/presentationml/2006/main">
   <p:cSld>
     <p:bg>
       <p:bgPr>
@@ -14933,7 +15109,14 @@
         <p:cNvGrpSpPr/>
         <p:nvPr/>
       </p:nvGrpSpPr>
-      <p:grpSpPr/>
+      <p:grpSpPr>
+        <a:xfrm>
+          <a:off x="0" y="0"/>
+          <a:ext cx="0" cy="0"/>
+          <a:chOff x="0" y="0"/>
+          <a:chExt cx="0" cy="0"/>
+        </a:xfrm>
+      </p:grpSpPr>
       <p:sp>
         <p:nvSpPr>
           <p:cNvPr id="2" name="TextBox 1"/>
@@ -15047,6 +15230,7 @@
           <a:lstStyle/>
           <a:p>
             <a:pPr algn="ctr"/>
+            <a:endParaRPr/>
           </a:p>
         </p:txBody>
       </p:sp>
@@ -15167,6 +15351,7 @@
           <a:lstStyle/>
           <a:p>
             <a:pPr algn="ctr"/>
+            <a:endParaRPr/>
           </a:p>
         </p:txBody>
       </p:sp>
@@ -15287,6 +15472,7 @@
           <a:lstStyle/>
           <a:p>
             <a:pPr algn="ctr"/>
+            <a:endParaRPr/>
           </a:p>
         </p:txBody>
       </p:sp>
@@ -15407,6 +15593,7 @@
           <a:lstStyle/>
           <a:p>
             <a:pPr algn="ctr"/>
+            <a:endParaRPr/>
           </a:p>
         </p:txBody>
       </p:sp>
@@ -15527,6 +15714,7 @@
           <a:lstStyle/>
           <a:p>
             <a:pPr algn="ctr"/>
+            <a:endParaRPr/>
           </a:p>
         </p:txBody>
       </p:sp>
@@ -15596,6 +15784,7 @@
                 <a:latin typeface="Calibri"/>
               </a:defRPr>
             </a:pPr>
+            <a:endParaRPr/>
           </a:p>
           <a:p>
             <a:pPr>

</xml_diff>